<commit_message>
revisi analisis Q2, Q3, Q4 dan rapikan validasi
- Q2: porsi tahap dihitung pakai rata-rata (86% transit, 14% gudang)
- Q3: cek dugaan RJ (ruang janji vs p90 transit), kategori produk tanpa LIMIT
- Q4b: pembanding Jan + Apr 2018, Feb tidak ikut dihitung
- Q5: koreksi angka ulasan dan nilai pesanan telat
- notebook validasi ambil angka SQL langsung lewat query
- path import relatif, screenshot dashboard di README
</commit_message>
<xml_diff>
--- a/07_presentation/Diagnosis_Keterlambatan_Pengiriman_Olist.pptx
+++ b/07_presentation/Diagnosis_Keterlambatan_Pengiriman_Olist.pptx
@@ -633,35 +633,29 @@
           </c:dLbls>
           <c:cat>
             <c:strRef>
-              <c:f>Sheet1!$A$2:$A$4</c:f>
+              <c:f>Sheet1!$A$2:$A$3</c:f>
               <c:strCache>
-                <c:ptCount val="3"/>
+                <c:ptCount val="2"/>
                 <c:pt idx="0">
                   <c:v>Transit kurir</c:v>
                 </c:pt>
                 <c:pt idx="1">
                   <c:v>Gudang penjual</c:v>
                 </c:pt>
-                <c:pt idx="2">
-                  <c:v>Efek median</c:v>
-                </c:pt>
               </c:strCache>
             </c:strRef>
           </c:cat>
           <c:val>
             <c:numRef>
-              <c:f>Sheet1!$B$2:$B$4</c:f>
+              <c:f>Sheet1!$B$2:$B$3</c:f>
               <c:numCache>
                 <c:formatCode>General</c:formatCode>
-                <c:ptCount val="3"/>
+                <c:ptCount val="2"/>
                 <c:pt idx="0">
-                  <c:v>87</c:v>
+                  <c:v>86.0</c:v>
                 </c:pt>
                 <c:pt idx="1">
-                  <c:v>7</c:v>
-                </c:pt>
-                <c:pt idx="2">
-                  <c:v>6</c:v>
+                  <c:v>14.0</c:v>
                 </c:pt>
               </c:numCache>
             </c:numRef>
@@ -847,13 +841,13 @@
                   <c:v>Espírito Santo</c:v>
                 </c:pt>
                 <c:pt idx="1">
-                  <c:v>Bahia</c:v>
+                  <c:v>Rio de Janeiro</c:v>
                 </c:pt>
                 <c:pt idx="2">
-                  <c:v>Rio de Janeiro</c:v>
+                  <c:v>Minas Gerais</c:v>
                 </c:pt>
                 <c:pt idx="3">
-                  <c:v>Minas Gerais</c:v>
+                  <c:v>Bahia</c:v>
                 </c:pt>
                 <c:pt idx="4">
                   <c:v>São Paulo</c:v>
@@ -868,19 +862,19 @@
                 <c:formatCode>General</c:formatCode>
                 <c:ptCount val="5"/>
                 <c:pt idx="0">
-                  <c:v>29.7</c:v>
+                  <c:v>30.4</c:v>
                 </c:pt>
                 <c:pt idx="1">
-                  <c:v>17.7</c:v>
+                  <c:v>26.5</c:v>
                 </c:pt>
                 <c:pt idx="2">
-                  <c:v>17.600000000000001</c:v>
+                  <c:v>19.8</c:v>
                 </c:pt>
                 <c:pt idx="3">
-                  <c:v>17.5</c:v>
+                  <c:v>19.5</c:v>
                 </c:pt>
                 <c:pt idx="4">
-                  <c:v>7</c:v>
+                  <c:v>8.7</c:v>
                 </c:pt>
               </c:numCache>
             </c:numRef>
@@ -2697,7 +2691,7 @@
                 <a:ea typeface="Calibri" pitchFamily="34" charset="-122"/>
                 <a:cs typeface="Calibri" pitchFamily="34" charset="-120"/>
               </a:rPr>
-              <a:t>Disusun oleh Operations Analyst untuk Head of Logistics &amp; Fulfillment</a:t>
+              <a:t>Disusun oleh Arif Herfian Zaen Chartiko (Operations Analyst) untuk Head of Logistics &amp; Fulfillment</a:t>
             </a:r>
             <a:endParaRPr lang="en-US" sz="1400" dirty="0"/>
           </a:p>
@@ -2852,6 +2846,10 @@
             <a:prstDash val="solid"/>
           </a:ln>
         </p:spPr>
+        <p:txBody>
+          <a:bodyPr/>
+          <a:p/>
+        </p:txBody>
       </p:sp>
       <p:sp>
         <p:nvSpPr>
@@ -2957,6 +2955,10 @@
             <a:prstDash val="solid"/>
           </a:ln>
         </p:spPr>
+        <p:txBody>
+          <a:bodyPr/>
+          <a:p/>
+        </p:txBody>
       </p:sp>
       <p:sp>
         <p:nvSpPr>
@@ -3062,6 +3064,10 @@
             <a:prstDash val="solid"/>
           </a:ln>
         </p:spPr>
+        <p:txBody>
+          <a:bodyPr/>
+          <a:p/>
+        </p:txBody>
       </p:sp>
       <p:sp>
         <p:nvSpPr>
@@ -3320,7 +3326,7 @@
                 <a:ea typeface="Calibri" pitchFamily="34" charset="-122"/>
                 <a:cs typeface="Calibri" pitchFamily="34" charset="-120"/>
               </a:rPr>
-              <a:t> Nasional (</a:t>
+              <a:t> Nasional (vs Jan + Apr 2018, Semua Provinsi Memburuk)</a:t>
             </a:r>
             <a:r>
               <a:rPr lang="en-US" sz="1300" b="1" dirty="0" err="1">
@@ -3331,7 +3337,7 @@
                 <a:ea typeface="Calibri" pitchFamily="34" charset="-122"/>
                 <a:cs typeface="Calibri" pitchFamily="34" charset="-120"/>
               </a:rPr>
-              <a:t>Semua</a:t>
+              <a:t/>
             </a:r>
             <a:r>
               <a:rPr lang="en-US" sz="1300" b="1" dirty="0">
@@ -3342,7 +3348,7 @@
                 <a:ea typeface="Calibri" pitchFamily="34" charset="-122"/>
                 <a:cs typeface="Calibri" pitchFamily="34" charset="-120"/>
               </a:rPr>
-              <a:t> </a:t>
+              <a:t/>
             </a:r>
             <a:r>
               <a:rPr lang="en-US" sz="1300" b="1" dirty="0" err="1">
@@ -3353,7 +3359,7 @@
                 <a:ea typeface="Calibri" pitchFamily="34" charset="-122"/>
                 <a:cs typeface="Calibri" pitchFamily="34" charset="-120"/>
               </a:rPr>
-              <a:t>Provinsi</a:t>
+              <a:t/>
             </a:r>
             <a:r>
               <a:rPr lang="en-US" sz="1300" b="1" dirty="0">
@@ -3364,7 +3370,7 @@
                 <a:ea typeface="Calibri" pitchFamily="34" charset="-122"/>
                 <a:cs typeface="Calibri" pitchFamily="34" charset="-120"/>
               </a:rPr>
-              <a:t> </a:t>
+              <a:t/>
             </a:r>
             <a:r>
               <a:rPr lang="en-US" sz="1300" b="1" dirty="0" err="1">
@@ -3375,7 +3381,7 @@
                 <a:ea typeface="Calibri" pitchFamily="34" charset="-122"/>
                 <a:cs typeface="Calibri" pitchFamily="34" charset="-120"/>
               </a:rPr>
-              <a:t>Memburuk</a:t>
+              <a:t/>
             </a:r>
             <a:r>
               <a:rPr lang="en-US" sz="1300" b="1" dirty="0">
@@ -3386,7 +3392,7 @@
                 <a:ea typeface="Calibri" pitchFamily="34" charset="-122"/>
                 <a:cs typeface="Calibri" pitchFamily="34" charset="-120"/>
               </a:rPr>
-              <a:t>)</a:t>
+              <a:t/>
             </a:r>
             <a:endParaRPr lang="en-US" sz="1300" dirty="0"/>
           </a:p>
@@ -3434,6 +3440,10 @@
             <a:prstDash val="solid"/>
           </a:ln>
         </p:spPr>
+        <p:txBody>
+          <a:bodyPr/>
+          <a:p/>
+        </p:txBody>
       </p:sp>
       <p:sp>
         <p:nvSpPr>
@@ -3454,6 +3464,10 @@
           </a:solidFill>
           <a:ln/>
         </p:spPr>
+        <p:txBody>
+          <a:bodyPr/>
+          <a:p/>
+        </p:txBody>
       </p:sp>
       <p:sp>
         <p:nvSpPr>
@@ -3569,7 +3583,7 @@
                 <a:ea typeface="Calibri" pitchFamily="34" charset="-122"/>
                 <a:cs typeface="Calibri" pitchFamily="34" charset="-120"/>
               </a:rPr>
-              <a:t>Dari 4,7% ke 11,7% atas 2.971 </a:t>
+              <a:t>Dari 3,0% ke 11,7% atas 2.971 </a:t>
             </a:r>
             <a:r>
               <a:rPr lang="en-US" sz="1150" dirty="0" err="1">
@@ -3653,6 +3667,10 @@
             <a:prstDash val="solid"/>
           </a:ln>
         </p:spPr>
+        <p:txBody>
+          <a:bodyPr/>
+          <a:p/>
+        </p:txBody>
       </p:sp>
       <p:sp>
         <p:nvSpPr>
@@ -3673,6 +3691,10 @@
           </a:solidFill>
           <a:ln/>
         </p:spPr>
+        <p:txBody>
+          <a:bodyPr/>
+          <a:p/>
+        </p:txBody>
       </p:sp>
       <p:sp>
         <p:nvSpPr>
@@ -4844,7 +4866,7 @@
                           <a:ea typeface="Calibri" pitchFamily="34" charset="-122"/>
                           <a:cs typeface="Calibri" pitchFamily="34" charset="-120"/>
                         </a:rPr>
-                        <a:t>61,29%</a:t>
+                        <a:t>61,25%</a:t>
                       </a:r>
                       <a:endParaRPr lang="en-US" sz="1150" dirty="0">
                         <a:latin typeface="Calibri" charset="0"/>
@@ -5367,7 +5389,7 @@
                 <a:ea typeface="Calibri" pitchFamily="34" charset="-122"/>
                 <a:cs typeface="Calibri" pitchFamily="34" charset="-120"/>
               </a:rPr>
-              <a:t> buruk melompat 3× (19,22% → 61,29%). Setelah hari ke-8, </a:t>
+              <a:t> buruk melompat 3× (19,22% → 61,25%). Setelah hari ke-8, </a:t>
             </a:r>
             <a:r>
               <a:rPr lang="en-US" sz="1100" dirty="0" err="1">
@@ -5443,6 +5465,10 @@
             <a:prstDash val="solid"/>
           </a:ln>
         </p:spPr>
+        <p:txBody>
+          <a:bodyPr/>
+          <a:p/>
+        </p:txBody>
       </p:sp>
       <p:sp>
         <p:nvSpPr>
@@ -5548,6 +5574,10 @@
             <a:prstDash val="solid"/>
           </a:ln>
         </p:spPr>
+        <p:txBody>
+          <a:bodyPr/>
+          <a:p/>
+        </p:txBody>
       </p:sp>
       <p:sp>
         <p:nvSpPr>
@@ -5653,6 +5683,10 @@
             <a:prstDash val="solid"/>
           </a:ln>
         </p:spPr>
+        <p:txBody>
+          <a:bodyPr/>
+          <a:p/>
+        </p:txBody>
       </p:sp>
       <p:sp>
         <p:nvSpPr>
@@ -5768,7 +5802,7 @@
                 <a:ea typeface="Calibri" pitchFamily="34" charset="-122"/>
                 <a:cs typeface="Calibri" pitchFamily="34" charset="-120"/>
               </a:rPr>
-              <a:t>BRL 1.123.857 </a:t>
+              <a:t>BRL 1.124.036 </a:t>
             </a:r>
             <a:r>
               <a:rPr lang="en-US" sz="1000" i="1" dirty="0" err="1">
@@ -6045,6 +6079,10 @@
           </a:solidFill>
           <a:ln/>
         </p:spPr>
+        <p:txBody>
+          <a:bodyPr/>
+          <a:p/>
+        </p:txBody>
       </p:sp>
       <p:sp>
         <p:nvSpPr>
@@ -6160,7 +6198,7 @@
                 <a:ea typeface="Calibri" pitchFamily="34" charset="-122"/>
                 <a:cs typeface="Calibri" pitchFamily="34" charset="-120"/>
               </a:rPr>
-              <a:t>87% selisih waktu telat vs tepat waktu ada di transit. Pembinaan penjual hanya menyentuh 7%.</a:t>
+              <a:t>86% selisih waktu telat vs tepat waktu ada di transit. Pembinaan penjual hanya menyentuh 14%.</a:t>
             </a:r>
             <a:endParaRPr lang="en-US" sz="1000" dirty="0"/>
           </a:p>
@@ -6187,6 +6225,10 @@
           </a:solidFill>
           <a:ln/>
         </p:spPr>
+        <p:txBody>
+          <a:bodyPr/>
+          <a:p/>
+        </p:txBody>
       </p:sp>
       <p:sp>
         <p:nvSpPr>
@@ -6395,6 +6437,10 @@
           </a:solidFill>
           <a:ln/>
         </p:spPr>
+        <p:txBody>
+          <a:bodyPr/>
+          <a:p/>
+        </p:txBody>
       </p:sp>
       <p:sp>
         <p:nvSpPr>
@@ -6559,6 +6605,10 @@
           </a:solidFill>
           <a:ln/>
         </p:spPr>
+        <p:txBody>
+          <a:bodyPr/>
+          <a:p/>
+        </p:txBody>
       </p:sp>
       <p:sp>
         <p:nvSpPr>
@@ -6745,6 +6795,10 @@
           </a:solidFill>
           <a:ln/>
         </p:spPr>
+        <p:txBody>
+          <a:bodyPr/>
+          <a:p/>
+        </p:txBody>
       </p:sp>
       <p:sp>
         <p:nvSpPr>
@@ -6860,7 +6914,7 @@
                 <a:ea typeface="Calibri" pitchFamily="34" charset="-122"/>
                 <a:cs typeface="Calibri" pitchFamily="34" charset="-120"/>
               </a:rPr>
-              <a:t>13,52% telat padahal transit hanya 8,38 hari (12.310 </a:t>
+              <a:t>13,52% telat padahal median transit 8,38 hari. Bukan soal janji: 10% pesanan paling lambat transit ≥24 hari. Telusuri ekor ini.</a:t>
             </a:r>
             <a:r>
               <a:rPr lang="en-US" sz="1000" dirty="0" err="1">
@@ -6871,7 +6925,7 @@
                 <a:ea typeface="Calibri" pitchFamily="34" charset="-122"/>
                 <a:cs typeface="Calibri" pitchFamily="34" charset="-120"/>
               </a:rPr>
-              <a:t>pesanan</a:t>
+              <a:t/>
             </a:r>
             <a:r>
               <a:rPr lang="en-US" sz="1000" dirty="0">
@@ -6882,7 +6936,7 @@
                 <a:ea typeface="Calibri" pitchFamily="34" charset="-122"/>
                 <a:cs typeface="Calibri" pitchFamily="34" charset="-120"/>
               </a:rPr>
-              <a:t>). </a:t>
+              <a:t/>
             </a:r>
             <a:r>
               <a:rPr lang="en-US" sz="1000" dirty="0" err="1">
@@ -6893,7 +6947,7 @@
                 <a:ea typeface="Calibri" pitchFamily="34" charset="-122"/>
                 <a:cs typeface="Calibri" pitchFamily="34" charset="-120"/>
               </a:rPr>
-              <a:t>Menunjuk</a:t>
+              <a:t/>
             </a:r>
             <a:r>
               <a:rPr lang="en-US" sz="1000" dirty="0">
@@ -6904,7 +6958,7 @@
                 <a:ea typeface="Calibri" pitchFamily="34" charset="-122"/>
                 <a:cs typeface="Calibri" pitchFamily="34" charset="-120"/>
               </a:rPr>
-              <a:t> ke rumus estimasi tanggal janji, bukan kecepatan kirim.</a:t>
+              <a:t/>
             </a:r>
             <a:endParaRPr lang="en-US" sz="1000" dirty="0"/>
           </a:p>
@@ -6931,6 +6985,10 @@
           </a:solidFill>
           <a:ln/>
         </p:spPr>
+        <p:txBody>
+          <a:bodyPr/>
+          <a:p/>
+        </p:txBody>
       </p:sp>
       <p:sp>
         <p:nvSpPr>
@@ -7068,7 +7126,7 @@
                 <a:ea typeface="Calibri" pitchFamily="34" charset="-122"/>
                 <a:cs typeface="Calibri" pitchFamily="34" charset="-120"/>
               </a:rPr>
-              <a:t> Gudang, Feb – Mar 2018 = gangguan jaringan kurir. Satu protokol untuk keduanya akan meleset.</a:t>
+              <a:t> gudang, Feb – Mar 2018 = gangguan jaringan kurir. Satu protokol untuk keduanya akan meleset.</a:t>
             </a:r>
             <a:endParaRPr lang="en-US" sz="1000" dirty="0"/>
           </a:p>
@@ -7218,6 +7276,10 @@
           </a:solidFill>
           <a:ln/>
         </p:spPr>
+        <p:txBody>
+          <a:bodyPr/>
+          <a:p/>
+        </p:txBody>
       </p:sp>
       <p:sp>
         <p:nvSpPr>
@@ -7365,6 +7427,10 @@
           </a:solidFill>
           <a:ln/>
         </p:spPr>
+        <p:txBody>
+          <a:bodyPr/>
+          <a:p/>
+        </p:txBody>
       </p:sp>
       <p:sp>
         <p:nvSpPr>
@@ -7490,6 +7556,10 @@
           </a:solidFill>
           <a:ln/>
         </p:spPr>
+        <p:txBody>
+          <a:bodyPr/>
+          <a:p/>
+        </p:txBody>
       </p:sp>
       <p:sp>
         <p:nvSpPr>
@@ -7566,7 +7636,7 @@
                 <a:ea typeface="Calibri" pitchFamily="34" charset="-122"/>
                 <a:cs typeface="Calibri" pitchFamily="34" charset="-120"/>
               </a:rPr>
-              <a:t>BRL 1.123.857 </a:t>
+              <a:t>BRL 1.124.036 </a:t>
             </a:r>
             <a:r>
               <a:rPr lang="en-US" sz="950" dirty="0" err="1">
@@ -7615,6 +7685,10 @@
           </a:solidFill>
           <a:ln/>
         </p:spPr>
+        <p:txBody>
+          <a:bodyPr/>
+          <a:p/>
+        </p:txBody>
       </p:sp>
       <p:sp>
         <p:nvSpPr>
@@ -7691,7 +7765,7 @@
                 <a:ea typeface="Calibri" pitchFamily="34" charset="-122"/>
                 <a:cs typeface="Calibri" pitchFamily="34" charset="-120"/>
               </a:rPr>
-              <a:t>646 pesanan tanpa ulasan dikeluarkan </a:t>
+              <a:t>643 pesanan tanpa ulasan dikeluarkan </a:t>
             </a:r>
             <a:r>
               <a:rPr lang="en-US" sz="950" dirty="0" err="1">
@@ -7762,6 +7836,10 @@
           </a:solidFill>
           <a:ln/>
         </p:spPr>
+        <p:txBody>
+          <a:bodyPr/>
+          <a:p/>
+        </p:txBody>
       </p:sp>
       <p:sp>
         <p:nvSpPr>
@@ -7887,6 +7965,10 @@
           </a:solidFill>
           <a:ln/>
         </p:spPr>
+        <p:txBody>
+          <a:bodyPr/>
+          <a:p/>
+        </p:txBody>
       </p:sp>
       <p:sp>
         <p:nvSpPr>
@@ -8175,7 +8257,7 @@
                 <a:ea typeface="Calibri" pitchFamily="34" charset="-122"/>
                 <a:cs typeface="Calibri" pitchFamily="34" charset="-120"/>
               </a:rPr>
-              <a:t>Terima kasih — Operations Analyst · Jan 2017–Ags 2018</a:t>
+              <a:t>Terima kasih — Arif Herfian Zaen Chartiko · Jan 2017–Ags 2018</a:t>
             </a:r>
             <a:endParaRPr lang="en-US" sz="1100" dirty="0"/>
           </a:p>
@@ -8330,6 +8412,10 @@
             <a:prstDash val="solid"/>
           </a:ln>
         </p:spPr>
+        <p:txBody>
+          <a:bodyPr/>
+          <a:p/>
+        </p:txBody>
       </p:sp>
       <p:sp>
         <p:nvSpPr>
@@ -8452,6 +8538,10 @@
             <a:prstDash val="solid"/>
           </a:ln>
         </p:spPr>
+        <p:txBody>
+          <a:bodyPr/>
+          <a:p/>
+        </p:txBody>
       </p:sp>
       <p:sp>
         <p:nvSpPr>
@@ -8574,6 +8664,10 @@
             <a:prstDash val="solid"/>
           </a:ln>
         </p:spPr>
+        <p:txBody>
+          <a:bodyPr/>
+          <a:p/>
+        </p:txBody>
       </p:sp>
       <p:sp>
         <p:nvSpPr>
@@ -8679,6 +8773,10 @@
             <a:prstDash val="solid"/>
           </a:ln>
         </p:spPr>
+        <p:txBody>
+          <a:bodyPr/>
+          <a:p/>
+        </p:txBody>
       </p:sp>
       <p:sp>
         <p:nvSpPr>
@@ -8801,6 +8899,10 @@
             <a:prstDash val="solid"/>
           </a:ln>
         </p:spPr>
+        <p:txBody>
+          <a:bodyPr/>
+          <a:p/>
+        </p:txBody>
       </p:sp>
       <p:sp>
         <p:nvSpPr>
@@ -8821,6 +8923,10 @@
           </a:solidFill>
           <a:ln/>
         </p:spPr>
+        <p:txBody>
+          <a:bodyPr/>
+          <a:p/>
+        </p:txBody>
       </p:sp>
       <p:sp>
         <p:nvSpPr>
@@ -8968,6 +9074,10 @@
             <a:prstDash val="solid"/>
           </a:ln>
         </p:spPr>
+        <p:txBody>
+          <a:bodyPr/>
+          <a:p/>
+        </p:txBody>
       </p:sp>
       <p:sp>
         <p:nvSpPr>
@@ -8988,6 +9098,10 @@
           </a:solidFill>
           <a:ln/>
         </p:spPr>
+        <p:txBody>
+          <a:bodyPr/>
+          <a:p/>
+        </p:txBody>
       </p:sp>
       <p:sp>
         <p:nvSpPr>
@@ -9103,7 +9217,7 @@
                 <a:ea typeface="Calibri" pitchFamily="34" charset="-122"/>
                 <a:cs typeface="Calibri" pitchFamily="34" charset="-120"/>
               </a:rPr>
-              <a:t>87% dari selisih waktu telat vs tepat waktu terjadi di tahap transit kurir, hanya 7% di gudang penjual. Pembinaan penjual tidak menyentuh akar masalah.</a:t>
+              <a:t>86% dari selisih waktu telat vs tepat waktu terjadi di tahap transit kurir, hanya 14% di gudang penjual. Pembinaan penjual tidak menyentuh akar masalah.</a:t>
             </a:r>
             <a:endParaRPr lang="en-US" sz="1150" dirty="0"/>
           </a:p>
@@ -9135,6 +9249,10 @@
             <a:prstDash val="solid"/>
           </a:ln>
         </p:spPr>
+        <p:txBody>
+          <a:bodyPr/>
+          <a:p/>
+        </p:txBody>
       </p:sp>
       <p:sp>
         <p:nvSpPr>
@@ -9155,6 +9273,10 @@
           </a:solidFill>
           <a:ln/>
         </p:spPr>
+        <p:txBody>
+          <a:bodyPr/>
+          <a:p/>
+        </p:txBody>
       </p:sp>
       <p:sp>
         <p:nvSpPr>
@@ -9314,7 +9436,7 @@
                 <a:ea typeface="Calibri" pitchFamily="34" charset="-122"/>
                 <a:cs typeface="Calibri" pitchFamily="34" charset="-120"/>
               </a:rPr>
-              <a:t> buruk melonjak dari 19,22% ke 61,29%.</a:t>
+              <a:t> buruk melonjak dari 19,22% ke 61,25%.</a:t>
             </a:r>
             <a:endParaRPr lang="en-US" sz="1150" dirty="0"/>
           </a:p>
@@ -9341,6 +9463,10 @@
           </a:solidFill>
           <a:ln/>
         </p:spPr>
+        <p:txBody>
+          <a:bodyPr/>
+          <a:p/>
+        </p:txBody>
       </p:sp>
       <p:sp>
         <p:nvSpPr>
@@ -9507,7 +9633,7 @@
                 <a:ea typeface="Calibri" pitchFamily="34" charset="-122"/>
                 <a:cs typeface="Calibri" pitchFamily="34" charset="-120"/>
               </a:rPr>
-              <a:t>	: 3.435 pelanggan kecewa berlebih, melekat pada pesanan senilai BRL 1.123.857</a:t>
+              <a:t>	: 3.435 pelanggan kecewa berlebih, melekat pada pesanan senilai BRL 1.124.036</a:t>
             </a:r>
             <a:endParaRPr lang="en-US" sz="1250" dirty="0"/>
           </a:p>
@@ -13728,7 +13854,7 @@
                 <a:ea typeface="Cambria" pitchFamily="34" charset="-122"/>
                 <a:cs typeface="Cambria" pitchFamily="34" charset="-120"/>
               </a:rPr>
-              <a:t>87% Selisih Waktu Terjadi di Transit Kurir, Bukan di Gudang</a:t>
+              <a:t>86% Selisih Waktu Terjadi di Transit Kurir, Bukan di Gudang</a:t>
             </a:r>
             <a:endParaRPr lang="en-US" sz="2400" dirty="0"/>
           </a:p>
@@ -14903,7 +15029,7 @@
                 <a:ea typeface="Calibri" pitchFamily="34" charset="-122"/>
                 <a:cs typeface="Calibri" pitchFamily="34" charset="-120"/>
               </a:rPr>
-              <a:t>Ketiga angka pada tiap baris adalah median terpisah, bukan penjumlahan — median dari total ≠ total dari median.</a:t>
+              <a:t>Ketiga angka pada tiap baris adalah median terpisah, bukan penjumlahan — median dari total ≠ total dari median. Porsi di grafik memakai rata-rata karena bisa dijumlahkan.</a:t>
             </a:r>
             <a:endParaRPr lang="en-US" sz="1050" dirty="0"/>
           </a:p>
@@ -14942,7 +15068,7 @@
                 <a:ea typeface="Calibri" pitchFamily="34" charset="-122"/>
                 <a:cs typeface="Calibri" pitchFamily="34" charset="-120"/>
               </a:rPr>
-              <a:t>Kontribusi terhadap Selisih 19,44 Hari</a:t>
+              <a:t>Kontribusi terhadap Selisih Rata-rata 20,64 Hari</a:t>
             </a:r>
             <a:endParaRPr lang="en-US" sz="1300" dirty="0"/>
           </a:p>
@@ -14985,6 +15111,10 @@
           </a:solidFill>
           <a:ln/>
         </p:spPr>
+        <p:txBody>
+          <a:bodyPr/>
+          <a:p/>
+        </p:txBody>
       </p:sp>
       <p:sp>
         <p:nvSpPr>
@@ -15033,7 +15163,7 @@
                 <a:ea typeface="Calibri" pitchFamily="34" charset="-122"/>
                 <a:cs typeface="Calibri" pitchFamily="34" charset="-120"/>
               </a:rPr>
-              <a:t>Gudang penjual ikut melambat pada pesanan telat, tapi kontribusinya kecil (7%) dan tidak menjelaskan besarnya masalah. Perbaikan sejak Apr 2018 membuktikan masalah ini dapat diselesaikan.</a:t>
+              <a:t>Gudang penjual ikut melambat pada pesanan telat, tapi kontribusinya kecil (14%) dan tidak menjelaskan besarnya masalah. Perbaikan sejak Apr 2018 membuktikan masalah ini dapat diselesaikan.</a:t>
             </a:r>
             <a:endParaRPr lang="en-US" sz="1400" dirty="0"/>
           </a:p>
@@ -19404,6 +19534,10 @@
             <a:prstDash val="solid"/>
           </a:ln>
         </p:spPr>
+        <p:txBody>
+          <a:bodyPr/>
+          <a:p/>
+        </p:txBody>
       </p:sp>
       <p:sp>
         <p:nvSpPr>
@@ -19424,6 +19558,10 @@
           </a:solidFill>
           <a:ln/>
         </p:spPr>
+        <p:txBody>
+          <a:bodyPr/>
+          <a:p/>
+        </p:txBody>
       </p:sp>
       <p:sp>
         <p:nvSpPr>
@@ -19539,7 +19677,7 @@
                 <a:ea typeface="Calibri" pitchFamily="34" charset="-122"/>
                 <a:cs typeface="Calibri" pitchFamily="34" charset="-120"/>
               </a:rPr>
-              <a:t>13,52% keterlambatan padahal transit hanya 8,38 </a:t>
+              <a:t>13,52% telat padahal median transit hanya 8,38 hari. Ruang janjinya setara MG (16,2 vs 16,4 hari), jadi bukan soal janji. Masalahnya di ekor: 10% pesanan paling lambat transit ≥24 hari, MG hanya 15 hari.</a:t>
             </a:r>
             <a:r>
               <a:rPr lang="en-US" sz="1150" dirty="0" err="1">
@@ -19550,7 +19688,7 @@
                 <a:ea typeface="Calibri" pitchFamily="34" charset="-122"/>
                 <a:cs typeface="Calibri" pitchFamily="34" charset="-120"/>
               </a:rPr>
-              <a:t>hari</a:t>
+              <a:t/>
             </a:r>
             <a:r>
               <a:rPr lang="en-US" sz="1150" dirty="0">
@@ -19561,7 +19699,7 @@
                 <a:ea typeface="Calibri" pitchFamily="34" charset="-122"/>
                 <a:cs typeface="Calibri" pitchFamily="34" charset="-120"/>
               </a:rPr>
-              <a:t>, jauh lebih cepat dari Maranhão/Pará. Volume 12.310 </a:t>
+              <a:t/>
             </a:r>
             <a:r>
               <a:rPr lang="en-US" sz="1150" dirty="0" err="1">
@@ -19572,7 +19710,7 @@
                 <a:ea typeface="Calibri" pitchFamily="34" charset="-122"/>
                 <a:cs typeface="Calibri" pitchFamily="34" charset="-120"/>
               </a:rPr>
-              <a:t>pesanan</a:t>
+              <a:t/>
             </a:r>
             <a:r>
               <a:rPr lang="en-US" sz="1150" dirty="0">
@@ -19583,7 +19721,7 @@
                 <a:ea typeface="Calibri" pitchFamily="34" charset="-122"/>
                 <a:cs typeface="Calibri" pitchFamily="34" charset="-120"/>
               </a:rPr>
-              <a:t> </a:t>
+              <a:t/>
             </a:r>
             <a:r>
               <a:rPr lang="en-US" sz="1150" dirty="0" err="1">
@@ -19594,7 +19732,7 @@
                 <a:ea typeface="Calibri" pitchFamily="34" charset="-122"/>
                 <a:cs typeface="Calibri" pitchFamily="34" charset="-120"/>
               </a:rPr>
-              <a:t>bukan</a:t>
+              <a:t/>
             </a:r>
             <a:r>
               <a:rPr lang="en-US" sz="1150" dirty="0">
@@ -19605,7 +19743,7 @@
                 <a:ea typeface="Calibri" pitchFamily="34" charset="-122"/>
                 <a:cs typeface="Calibri" pitchFamily="34" charset="-120"/>
               </a:rPr>
-              <a:t> kasus kecil. Dugaan paling </a:t>
+              <a:t/>
             </a:r>
             <a:r>
               <a:rPr lang="en-US" sz="1150" dirty="0" err="1">
@@ -19616,7 +19754,7 @@
                 <a:ea typeface="Calibri" pitchFamily="34" charset="-122"/>
                 <a:cs typeface="Calibri" pitchFamily="34" charset="-120"/>
               </a:rPr>
-              <a:t>masuk</a:t>
+              <a:t/>
             </a:r>
             <a:r>
               <a:rPr lang="en-US" sz="1150" dirty="0">
@@ -19627,7 +19765,7 @@
                 <a:ea typeface="Calibri" pitchFamily="34" charset="-122"/>
                 <a:cs typeface="Calibri" pitchFamily="34" charset="-120"/>
               </a:rPr>
-              <a:t> </a:t>
+              <a:t/>
             </a:r>
             <a:r>
               <a:rPr lang="en-US" sz="1150" dirty="0" err="1">
@@ -19638,7 +19776,7 @@
                 <a:ea typeface="Calibri" pitchFamily="34" charset="-122"/>
                 <a:cs typeface="Calibri" pitchFamily="34" charset="-120"/>
               </a:rPr>
-              <a:t>akal</a:t>
+              <a:t/>
             </a:r>
             <a:r>
               <a:rPr lang="en-US" sz="1150" dirty="0">
@@ -19649,7 +19787,7 @@
                 <a:ea typeface="Calibri" pitchFamily="34" charset="-122"/>
                 <a:cs typeface="Calibri" pitchFamily="34" charset="-120"/>
               </a:rPr>
-              <a:t> </a:t>
+              <a:t/>
             </a:r>
             <a:r>
               <a:rPr lang="en-US" sz="1150" dirty="0" err="1">
@@ -19660,7 +19798,7 @@
                 <a:ea typeface="Calibri" pitchFamily="34" charset="-122"/>
                 <a:cs typeface="Calibri" pitchFamily="34" charset="-120"/>
               </a:rPr>
-              <a:t>adalah</a:t>
+              <a:t/>
             </a:r>
             <a:r>
               <a:rPr lang="en-US" sz="1150" dirty="0">
@@ -19671,7 +19809,7 @@
                 <a:ea typeface="Calibri" pitchFamily="34" charset="-122"/>
                 <a:cs typeface="Calibri" pitchFamily="34" charset="-120"/>
               </a:rPr>
-              <a:t> tanggal janji terlalu optimis, bukan soal jarak/jaringan.</a:t>
+              <a:t/>
             </a:r>
             <a:endParaRPr lang="en-US" sz="1150" dirty="0"/>
           </a:p>
@@ -19703,6 +19841,10 @@
             <a:prstDash val="solid"/>
           </a:ln>
         </p:spPr>
+        <p:txBody>
+          <a:bodyPr/>
+          <a:p/>
+        </p:txBody>
       </p:sp>
       <p:sp>
         <p:nvSpPr>
@@ -19723,6 +19865,10 @@
           </a:solidFill>
           <a:ln/>
         </p:spPr>
+        <p:txBody>
+          <a:bodyPr/>
+          <a:p/>
+        </p:txBody>
       </p:sp>
       <p:sp>
         <p:nvSpPr>
@@ -19838,7 +19984,7 @@
                 <a:ea typeface="Calibri" pitchFamily="34" charset="-122"/>
                 <a:cs typeface="Calibri" pitchFamily="34" charset="-120"/>
               </a:rPr>
-              <a:t>Perbedaan telat antarkategori produk tidak menunjukkan pola yang cukup kuat untuk ditindaklanjuti, termasuk setelah berat produk diperhitungkan.</a:t>
+              <a:t>21 kategori berada di rentang 5,39% - 9,75%, jauh lebih sempit dari antarprovinsi (5,02% - 19,64%). Berat produk juga tidak berpola.</a:t>
             </a:r>
             <a:endParaRPr lang="en-US" sz="1150" dirty="0"/>
           </a:p>

</xml_diff>